<commit_message>
docs: Add new seminar entry and associated PDF, update fanpage slides, and simplify the Q Projects section on the research page.
</commit_message>
<xml_diff>
--- a/images/slides/quantum_class_thChương.pptx
+++ b/images/slides/quantum_class_thChương.pptx
@@ -200,7 +200,7 @@
           <a:p>
             <a:fld id="{52A2B7F2-4ED9-403D-8D8A-879FE3B4014E}" type="datetimeFigureOut">
               <a:rPr lang="en-US" smtClean="0"/>
-              <a:t>2/25/26</a:t>
+              <a:t>3/4/26</a:t>
             </a:fld>
             <a:endParaRPr lang="en-US"/>
           </a:p>
@@ -914,7 +914,7 @@
           <a:p>
             <a:fld id="{A04A5567-2D39-432B-A86B-39F40DF129FF}" type="datetimeFigureOut">
               <a:rPr lang="en-US" smtClean="0"/>
-              <a:t>2/25/26</a:t>
+              <a:t>3/4/26</a:t>
             </a:fld>
             <a:endParaRPr lang="en-US"/>
           </a:p>
@@ -1112,7 +1112,7 @@
           <a:p>
             <a:fld id="{A04A5567-2D39-432B-A86B-39F40DF129FF}" type="datetimeFigureOut">
               <a:rPr lang="en-US" smtClean="0"/>
-              <a:t>2/25/26</a:t>
+              <a:t>3/4/26</a:t>
             </a:fld>
             <a:endParaRPr lang="en-US"/>
           </a:p>
@@ -1320,7 +1320,7 @@
           <a:p>
             <a:fld id="{A04A5567-2D39-432B-A86B-39F40DF129FF}" type="datetimeFigureOut">
               <a:rPr lang="en-US" smtClean="0"/>
-              <a:t>2/25/26</a:t>
+              <a:t>3/4/26</a:t>
             </a:fld>
             <a:endParaRPr lang="en-US"/>
           </a:p>
@@ -1518,7 +1518,7 @@
           <a:p>
             <a:fld id="{A04A5567-2D39-432B-A86B-39F40DF129FF}" type="datetimeFigureOut">
               <a:rPr lang="en-US" smtClean="0"/>
-              <a:t>2/25/26</a:t>
+              <a:t>3/4/26</a:t>
             </a:fld>
             <a:endParaRPr lang="en-US"/>
           </a:p>
@@ -1793,7 +1793,7 @@
           <a:p>
             <a:fld id="{A04A5567-2D39-432B-A86B-39F40DF129FF}" type="datetimeFigureOut">
               <a:rPr lang="en-US" smtClean="0"/>
-              <a:t>2/25/26</a:t>
+              <a:t>3/4/26</a:t>
             </a:fld>
             <a:endParaRPr lang="en-US"/>
           </a:p>
@@ -2058,7 +2058,7 @@
           <a:p>
             <a:fld id="{A04A5567-2D39-432B-A86B-39F40DF129FF}" type="datetimeFigureOut">
               <a:rPr lang="en-US" smtClean="0"/>
-              <a:t>2/25/26</a:t>
+              <a:t>3/4/26</a:t>
             </a:fld>
             <a:endParaRPr lang="en-US"/>
           </a:p>
@@ -2470,7 +2470,7 @@
           <a:p>
             <a:fld id="{A04A5567-2D39-432B-A86B-39F40DF129FF}" type="datetimeFigureOut">
               <a:rPr lang="en-US" smtClean="0"/>
-              <a:t>2/25/26</a:t>
+              <a:t>3/4/26</a:t>
             </a:fld>
             <a:endParaRPr lang="en-US"/>
           </a:p>
@@ -2611,7 +2611,7 @@
           <a:p>
             <a:fld id="{A04A5567-2D39-432B-A86B-39F40DF129FF}" type="datetimeFigureOut">
               <a:rPr lang="en-US" smtClean="0"/>
-              <a:t>2/25/26</a:t>
+              <a:t>3/4/26</a:t>
             </a:fld>
             <a:endParaRPr lang="en-US"/>
           </a:p>
@@ -2724,7 +2724,7 @@
           <a:p>
             <a:fld id="{A04A5567-2D39-432B-A86B-39F40DF129FF}" type="datetimeFigureOut">
               <a:rPr lang="en-US" smtClean="0"/>
-              <a:t>2/25/26</a:t>
+              <a:t>3/4/26</a:t>
             </a:fld>
             <a:endParaRPr lang="en-US"/>
           </a:p>
@@ -3035,7 +3035,7 @@
           <a:p>
             <a:fld id="{A04A5567-2D39-432B-A86B-39F40DF129FF}" type="datetimeFigureOut">
               <a:rPr lang="en-US" smtClean="0"/>
-              <a:t>2/25/26</a:t>
+              <a:t>3/4/26</a:t>
             </a:fld>
             <a:endParaRPr lang="en-US"/>
           </a:p>
@@ -3323,7 +3323,7 @@
           <a:p>
             <a:fld id="{A04A5567-2D39-432B-A86B-39F40DF129FF}" type="datetimeFigureOut">
               <a:rPr lang="en-US" smtClean="0"/>
-              <a:t>2/25/26</a:t>
+              <a:t>3/4/26</a:t>
             </a:fld>
             <a:endParaRPr lang="en-US"/>
           </a:p>
@@ -3564,7 +3564,7 @@
           <a:p>
             <a:fld id="{A04A5567-2D39-432B-A86B-39F40DF129FF}" type="datetimeFigureOut">
               <a:rPr lang="en-US" smtClean="0"/>
-              <a:t>2/25/26</a:t>
+              <a:t>3/4/26</a:t>
             </a:fld>
             <a:endParaRPr lang="en-US"/>
           </a:p>
@@ -7567,7 +7567,7 @@
                   <a:schemeClr val="bg1"/>
                 </a:solidFill>
               </a:rPr>
-              <a:t> 05/03/ – 23/05/2026 </a:t>
+              <a:t> 05/03/ – 23/04/2026 </a:t>
             </a:r>
           </a:p>
         </p:txBody>

</xml_diff>